<commit_message>
More fig 15 revisions
</commit_message>
<xml_diff>
--- a/fig_15/fig_15_EtalonModes.pptx
+++ b/fig_15/fig_15_EtalonModes.pptx
@@ -6656,9 +6656,7 @@
               <a:schemeClr val="bg1"/>
             </a:solidFill>
             <a:ln>
-              <a:solidFill>
-                <a:schemeClr val="bg1"/>
-              </a:solidFill>
+              <a:noFill/>
             </a:ln>
           </p:spPr>
           <p:style>

</xml_diff>